<commit_message>
Rebuild the example decks on the new slide theme
</commit_message>
<xml_diff>
--- a/example/outputs/reports/slides.pptx
+++ b/example/outputs/reports/slides.pptx
@@ -10,7 +10,6 @@
     <p:sldId id="258" r:id="rId4"/>
     <p:sldId id="259" r:id="rId5"/>
     <p:sldId id="260" r:id="rId6"/>
-    <p:sldId id="261" r:id="rId7"/>
   </p:sldIdLst>
   <p:sldSz cx="9144000" cy="5143500" type="screen16x9"/>
   <p:notesSz cx="6858000" cy="9144000"/>
@@ -157,8 +156,8 @@
         </p:nvSpPr>
         <p:spPr>
           <a:xfrm>
-            <a:off x="457200" y="1500000"/>
-            <a:ext cx="8229600" cy="1100000"/>
+            <a:off x="757200" y="1150000"/>
+            <a:ext cx="7929600" cy="1100000"/>
           </a:xfrm>
         </p:spPr>
         <p:txBody>
@@ -168,7 +167,7 @@
               <a:buNone/>
               <a:defRPr sz="3600" b="1">
                 <a:solidFill>
-                  <a:srgbClr val="111111"/>
+                  <a:srgbClr val="1A1A1A"/>
                 </a:solidFill>
               </a:defRPr>
             </a:lvl1pPr>
@@ -193,8 +192,8 @@
         </p:nvSpPr>
         <p:spPr>
           <a:xfrm>
-            <a:off x="457200" y="2800000"/>
-            <a:ext cx="8229600" cy="600000"/>
+            <a:off x="757200" y="2250000"/>
+            <a:ext cx="7929600" cy="700000"/>
           </a:xfrm>
         </p:spPr>
         <p:txBody>
@@ -204,7 +203,7 @@
               <a:buNone/>
               <a:defRPr sz="2000" b="0">
                 <a:solidFill>
-                  <a:srgbClr val="8B0000"/>
+                  <a:srgbClr val="4A4A4A"/>
                 </a:solidFill>
               </a:defRPr>
             </a:lvl1pPr>
@@ -282,23 +281,95 @@
           </a:p>
         </p:txBody>
       </p:sp>
+      <p:pic>
+        <p:nvPicPr>
+          <p:cNvPr id="910" name="Logo 1" descr="logos/mcgill.png"/>
+          <p:cNvPicPr>
+            <a:picLocks noChangeAspect="1"/>
+          </p:cNvPicPr>
+          <p:nvPr/>
+        </p:nvPicPr>
+        <p:blipFill>
+          <a:blip r:embed="rId2"/>
+          <a:stretch>
+            <a:fillRect/>
+          </a:stretch>
+        </p:blipFill>
+        <p:spPr>
+          <a:xfrm>
+            <a:off x="1974245" y="4173500"/>
+            <a:ext cx="1852500" cy="520000"/>
+          </a:xfrm>
+          <a:prstGeom prst="rect">
+            <a:avLst/>
+          </a:prstGeom>
+        </p:spPr>
+      </p:pic>
+      <p:pic>
+        <p:nvPicPr>
+          <p:cNvPr id="911" name="Logo 2" descr="logos/douglas.png"/>
+          <p:cNvPicPr>
+            <a:picLocks noChangeAspect="1"/>
+          </p:cNvPicPr>
+          <p:nvPr/>
+        </p:nvPicPr>
+        <p:blipFill>
+          <a:blip r:embed="rId3"/>
+          <a:stretch>
+            <a:fillRect/>
+          </a:stretch>
+        </p:blipFill>
+        <p:spPr>
+          <a:xfrm>
+            <a:off x="4346745" y="4173500"/>
+            <a:ext cx="1469565" cy="520000"/>
+          </a:xfrm>
+          <a:prstGeom prst="rect">
+            <a:avLst/>
+          </a:prstGeom>
+        </p:spPr>
+      </p:pic>
+      <p:pic>
+        <p:nvPicPr>
+          <p:cNvPr id="912" name="Logo 3" descr="logos/stopad.png"/>
+          <p:cNvPicPr>
+            <a:picLocks noChangeAspect="1"/>
+          </p:cNvPicPr>
+          <p:nvPr/>
+        </p:nvPicPr>
+        <p:blipFill>
+          <a:blip r:embed="rId4"/>
+          <a:stretch>
+            <a:fillRect/>
+          </a:stretch>
+        </p:blipFill>
+        <p:spPr>
+          <a:xfrm>
+            <a:off x="6336310" y="4173500"/>
+            <a:ext cx="833444" cy="520000"/>
+          </a:xfrm>
+          <a:prstGeom prst="rect">
+            <a:avLst/>
+          </a:prstGeom>
+        </p:spPr>
+      </p:pic>
       <p:cxnSp>
         <p:nvCxnSpPr>
-          <p:cNvPr id="900" name="Title rule"/>
+          <p:cNvPr id="900" name="Title bar"/>
           <p:cNvCxnSpPr/>
           <p:nvPr userDrawn="1"/>
         </p:nvCxnSpPr>
         <p:spPr>
           <a:xfrm>
-            <a:off x="457200" y="2700000"/>
-            <a:ext cx="8229600" cy="0"/>
+            <a:off x="457200" y="1150000"/>
+            <a:ext cx="0" cy="1800000"/>
           </a:xfrm>
           <a:prstGeom prst="line">
             <a:avLst/>
           </a:prstGeom>
-          <a:ln w="25400">
+          <a:ln w="50800">
             <a:solidFill>
-              <a:srgbClr val="8B0000"/>
+              <a:srgbClr val="ED1B2F"/>
             </a:solidFill>
           </a:ln>
         </p:spPr>
@@ -2061,7 +2132,7 @@
               <a:buNone/>
               <a:defRPr sz="2600" b="1">
                 <a:solidFill>
-                  <a:srgbClr val="111111"/>
+                  <a:srgbClr val="1A1A1A"/>
                 </a:solidFill>
               </a:defRPr>
             </a:lvl1pPr>
@@ -2759,27 +2830,6 @@
           </a:p>
         </p:txBody>
       </p:sp>
-      <p:cxnSp>
-        <p:nvCxnSpPr>
-          <p:cNvPr id="900" name="Title rule"/>
-          <p:cNvCxnSpPr/>
-          <p:nvPr userDrawn="1"/>
-        </p:nvCxnSpPr>
-        <p:spPr>
-          <a:xfrm>
-            <a:off x="457200" y="800000"/>
-            <a:ext cx="8229600" cy="0"/>
-          </a:xfrm>
-          <a:prstGeom prst="line">
-            <a:avLst/>
-          </a:prstGeom>
-          <a:ln w="19050">
-            <a:solidFill>
-              <a:srgbClr val="8B0000"/>
-            </a:solidFill>
-          </a:ln>
-        </p:spPr>
-      </p:cxnSp>
     </p:spTree>
     <p:extLst>
       <p:ext uri="{BB962C8B-B14F-4D97-AF65-F5344CB8AC3E}">
@@ -3083,8 +3133,8 @@
         </p:nvSpPr>
         <p:spPr>
           <a:xfrm>
-            <a:off x="457200" y="1500000"/>
-            <a:ext cx="8229600" cy="1100000"/>
+            <a:off x="757200" y="1150000"/>
+            <a:ext cx="7929600" cy="1100000"/>
           </a:xfrm>
         </p:spPr>
         <p:txBody>
@@ -3113,8 +3163,8 @@
         </p:nvSpPr>
         <p:spPr>
           <a:xfrm>
-            <a:off x="457200" y="2800000"/>
-            <a:ext cx="8229600" cy="600000"/>
+            <a:off x="757200" y="2250000"/>
+            <a:ext cx="7929600" cy="700000"/>
           </a:xfrm>
         </p:spPr>
         <p:txBody>
@@ -3128,6 +3178,8 @@
               <a:rPr/>
               <a:t>A worked example of the R analysis project template</a:t>
             </a:r>
+            <a:br/>
+            <a:br/>
           </a:p>
         </p:txBody>
       </p:sp>
@@ -3151,7 +3203,7 @@
             </a:pPr>
             <a:r>
               <a:rPr/>
-              <a:t>October 7, 2026</a:t>
+              <a:t>October 8, 2026</a:t>
             </a:r>
           </a:p>
         </p:txBody>
@@ -3203,7 +3255,7 @@
             </a:pPr>
             <a:r>
               <a:rPr/>
-              <a:t>Question and data</a:t>
+              <a:t>How much heavier are males, and does it depend on the species?</a:t>
             </a:r>
           </a:p>
         </p:txBody>
@@ -3225,47 +3277,13 @@
         <a:graphic>
           <a:graphicData uri="http://schemas.openxmlformats.org/drawingml/2006/table">
             <a:tbl>
-              <a:tblPr firstRow="1" bandRow="1">
+              <a:tblPr firstRow="0" bandRow="1">
                 <a:tableStyleId>{5C22544A-7EE6-4342-B048-85BDC9FD1C3A}</a:tableStyleId>
               </a:tblPr>
               <a:tblGrid>
                 <a:gridCol w="2057400"/>
                 <a:gridCol w="6172200"/>
               </a:tblGrid>
-              <a:tr h="0">
-                <a:tc>
-                  <a:txBody>
-                    <a:bodyPr/>
-                    <a:lstStyle/>
-                    <a:p>
-                      <a:pPr lvl="0" indent="0" marL="0">
-                        <a:buNone/>
-                      </a:pPr>
-                      <a:r>
-                        <a:rPr/>
-                        <a:t>Question</a:t>
-                      </a:r>
-                    </a:p>
-                  </a:txBody>
-                  <a:tcPr/>
-                </a:tc>
-                <a:tc>
-                  <a:txBody>
-                    <a:bodyPr/>
-                    <a:lstStyle/>
-                    <a:p>
-                      <a:pPr lvl="0" indent="0" marL="0">
-                        <a:buNone/>
-                      </a:pPr>
-                      <a:r>
-                        <a:rPr/>
-                        <a:t>How much heavier are male penguins than females, and does the difference depend on the species?</a:t>
-                      </a:r>
-                    </a:p>
-                  </a:txBody>
-                  <a:tcPr/>
-                </a:tc>
-              </a:tr>
               <a:tr h="0">
                 <a:tc>
                   <a:txBody>
@@ -3444,7 +3462,7 @@
             </a:pPr>
             <a:r>
               <a:rPr/>
-              <a:t>Points: individual penguins. Black: means with 95% confidence intervals.</a:t>
+              <a:t>333 penguins. Points: individual penguins. Black: means with 95% confidence intervals.</a:t>
             </a:r>
           </a:p>
         </p:txBody>
@@ -3526,7 +3544,7 @@
             </a:pPr>
             <a:r>
               <a:rPr/>
-              <a:t>Male minus female body mass</a:t>
+              <a:t>The difference is largest in Gentoo penguins</a:t>
             </a:r>
           </a:p>
         </p:txBody>
@@ -3551,7 +3569,7 @@
             </a:pPr>
             <a:r>
               <a:rPr/>
-              <a:t>Difference in means within each species, with its Welch confidence interval at 95%.</a:t>
+              <a:t>Male minus female mean body mass within each species, with a Welch confidence interval (CI).</a:t>
             </a:r>
           </a:p>
         </p:txBody>
@@ -3668,7 +3686,7 @@
                       </a:pPr>
                       <a:r>
                         <a:rPr/>
-                        <a:t>675 [573, 776]</a:t>
+                        <a:t>675</a:t>
                       </a:r>
                     </a:p>
                   </a:txBody>
@@ -3683,7 +3701,7 @@
                       </a:pPr>
                       <a:r>
                         <a:rPr/>
-                        <a:t>412 [254, 570]</a:t>
+                        <a:t>412</a:t>
                       </a:r>
                     </a:p>
                   </a:txBody>
@@ -3698,7 +3716,69 @@
                       </a:pPr>
                       <a:r>
                         <a:rPr/>
-                        <a:t>805 [697, 913]</a:t>
+                        <a:t>805</a:t>
+                      </a:r>
+                    </a:p>
+                  </a:txBody>
+                </a:tc>
+              </a:tr>
+              <a:tr h="0">
+                <a:tc>
+                  <a:txBody>
+                    <a:bodyPr/>
+                    <a:lstStyle/>
+                    <a:p>
+                      <a:pPr lvl="0" indent="0" marL="0">
+                        <a:buNone/>
+                      </a:pPr>
+                      <a:r>
+                        <a:rPr b="1"/>
+                        <a:t>95% CI (g)</a:t>
+                      </a:r>
+                    </a:p>
+                  </a:txBody>
+                </a:tc>
+                <a:tc>
+                  <a:txBody>
+                    <a:bodyPr/>
+                    <a:lstStyle/>
+                    <a:p>
+                      <a:pPr lvl="0" indent="0" marL="0">
+                        <a:buNone/>
+                      </a:pPr>
+                      <a:r>
+                        <a:rPr/>
+                        <a:t>573 to 776</a:t>
+                      </a:r>
+                    </a:p>
+                  </a:txBody>
+                </a:tc>
+                <a:tc>
+                  <a:txBody>
+                    <a:bodyPr/>
+                    <a:lstStyle/>
+                    <a:p>
+                      <a:pPr lvl="0" indent="0" marL="0">
+                        <a:buNone/>
+                      </a:pPr>
+                      <a:r>
+                        <a:rPr/>
+                        <a:t>254 to 570</a:t>
+                      </a:r>
+                    </a:p>
+                  </a:txBody>
+                </a:tc>
+                <a:tc>
+                  <a:txBody>
+                    <a:bodyPr/>
+                    <a:lstStyle/>
+                    <a:p>
+                      <a:pPr lvl="0" indent="0" marL="0">
+                        <a:buNone/>
+                      </a:pPr>
+                      <a:r>
+                        <a:rPr/>
+                        <a:t>697 to 913</a:t>
                       </a:r>
                     </a:p>
                   </a:txBody>
@@ -3817,161 +3897,256 @@
             </a:pPr>
             <a:r>
               <a:rPr/>
-              <a:t>Adjusted for species</a:t>
-            </a:r>
-          </a:p>
-        </p:txBody>
-      </p:sp>
-      <p:sp>
-        <p:nvSpPr>
-          <p:cNvPr id="3" name="Content Placeholder 2"/>
-          <p:cNvSpPr>
-            <a:spLocks noGrp="1"/>
-          </p:cNvSpPr>
+              <a:t>Adjusted for species, males are heavier by 668 g</a:t>
+            </a:r>
+          </a:p>
+        </p:txBody>
+      </p:sp>
+      <p:sp>
+        <p:nvSpPr>
+          <p:cNvPr id="4" name="Text Placeholder 3"/>
+          <p:cNvSpPr>
+            <a:spLocks noGrp="1"/>
+          </p:cNvSpPr>
+          <p:nvPr>
+            <p:ph idx="2" sz="half" type="body"/>
+          </p:nvPr>
+        </p:nvSpPr>
+        <p:spPr/>
+        <p:txBody>
+          <a:bodyPr/>
+          <a:lstStyle/>
+          <a:p>
+            <a:pPr lvl="0" indent="0" marL="0">
+              <a:buNone/>
+            </a:pPr>
+            <a:r>
+              <a:rPr/>
+              <a:t>Linear model of body mass on species and sex; 333 penguins; R² 0.85. Chinstrap and Adelie penguins of the same sex do not clearly differ. The model assumes one difference for all species, while within species it ranges from 412 to 805 g.</a:t>
+            </a:r>
+          </a:p>
+        </p:txBody>
+      </p:sp>
+      <p:graphicFrame>
+        <p:nvGraphicFramePr>
+          <p:cNvPr id="6" name="Content Placeholder 5"/>
+          <p:cNvGraphicFramePr>
+            <a:graphicFrameLocks noGrp="1"/>
+          </p:cNvGraphicFramePr>
           <p:nvPr>
             <p:ph idx="1"/>
           </p:nvPr>
-        </p:nvSpPr>
-        <p:spPr/>
-        <p:txBody>
-          <a:bodyPr/>
-          <a:lstStyle/>
-          <a:p>
-            <a:pPr lvl="0"/>
-            <a:r>
-              <a:rPr b="1"/>
-              <a:t>Males</a:t>
-            </a:r>
-            <a:r>
-              <a:rPr/>
-              <a:t> heavier by 668 [599, 736] g</a:t>
-            </a:r>
-          </a:p>
-          <a:p>
-            <a:pPr lvl="0"/>
-            <a:r>
-              <a:rPr b="1"/>
-              <a:t>Gentoo</a:t>
-            </a:r>
-            <a:r>
-              <a:rPr/>
-              <a:t> heavier than Adelie of the same sex, by 1378 [1301, 1455] g</a:t>
-            </a:r>
-          </a:p>
-          <a:p>
-            <a:pPr lvl="0"/>
-            <a:r>
-              <a:rPr b="1"/>
-              <a:t>Chinstrap</a:t>
-            </a:r>
-            <a:r>
-              <a:rPr/>
-              <a:t> and Adelie: 27 [−65, 118] g, no clear difference</a:t>
-            </a:r>
-          </a:p>
-          <a:p>
-            <a:pPr lvl="0"/>
-            <a:r>
-              <a:rPr b="1"/>
-              <a:t>Model:</a:t>
-            </a:r>
-            <a:r>
-              <a:rPr/>
-              <a:t> body mass on species and sex, 333 penguins, R² 0.85</a:t>
-            </a:r>
-          </a:p>
-        </p:txBody>
-      </p:sp>
-    </p:spTree>
-  </p:cSld>
-</p:sld>
-</file>
-
-<file path=ppt/slides/slide6.xml><?xml version="1.0" encoding="utf-8"?>
-<p:sld xmlns:a="http://schemas.openxmlformats.org/drawingml/2006/main" xmlns:r="http://schemas.openxmlformats.org/officeDocument/2006/relationships" xmlns:p="http://schemas.openxmlformats.org/presentationml/2006/main">
-  <p:cSld>
-    <p:spTree>
-      <p:nvGrpSpPr>
-        <p:cNvPr id="1" name=""/>
-        <p:cNvGrpSpPr/>
-        <p:nvPr/>
-      </p:nvGrpSpPr>
-      <p:grpSpPr>
-        <a:xfrm>
-          <a:off x="0" y="0"/>
-          <a:ext cx="0" cy="0"/>
-          <a:chOff x="0" y="0"/>
-          <a:chExt cx="0" cy="0"/>
-        </a:xfrm>
-      </p:grpSpPr>
-      <p:sp>
-        <p:nvSpPr>
-          <p:cNvPr id="2" name="Title 1"/>
-          <p:cNvSpPr>
-            <a:spLocks noGrp="1"/>
-          </p:cNvSpPr>
-          <p:nvPr>
-            <p:ph type="title"/>
-          </p:nvPr>
-        </p:nvSpPr>
-        <p:spPr>
-          <a:xfrm>
-            <a:off x="457200" y="200000"/>
-            <a:ext cx="8229600" cy="560000"/>
-          </a:xfrm>
-        </p:spPr>
-        <p:txBody>
-          <a:bodyPr/>
-          <a:lstStyle/>
-          <a:p>
-            <a:pPr lvl="0" indent="0" marL="0">
-              <a:buNone/>
-            </a:pPr>
-            <a:r>
-              <a:rPr/>
-              <a:t>Caveats</a:t>
-            </a:r>
-          </a:p>
-        </p:txBody>
-      </p:sp>
-      <p:sp>
-        <p:nvSpPr>
-          <p:cNvPr id="3" name="Content Placeholder 2"/>
-          <p:cNvSpPr>
-            <a:spLocks noGrp="1"/>
-          </p:cNvSpPr>
-          <p:nvPr>
-            <p:ph idx="1"/>
-          </p:nvPr>
-        </p:nvSpPr>
-        <p:spPr/>
-        <p:txBody>
-          <a:bodyPr/>
-          <a:lstStyle/>
-          <a:p>
-            <a:pPr lvl="0"/>
-            <a:r>
-              <a:rPr b="1"/>
-              <a:t>One difference for all species:</a:t>
-            </a:r>
-            <a:r>
-              <a:rPr/>
-              <a:t> the model assumes it; the within-species differences range from 412 to 805 g</a:t>
-            </a:r>
-          </a:p>
-          <a:p>
-            <a:pPr lvl="0"/>
-            <a:r>
-              <a:rPr b="1"/>
-              <a:t>Complete records only:</a:t>
-            </a:r>
-            <a:r>
-              <a:rPr/>
-              <a:t> 11 penguins without a recorded sex are left out</a:t>
-            </a:r>
-          </a:p>
-        </p:txBody>
-      </p:sp>
+        </p:nvGraphicFramePr>
+        <p:xfrm>
+          <a:off x="457200" y="939800"/>
+          <a:ext cx="8229600" cy="3035300"/>
+        </p:xfrm>
+        <a:graphic>
+          <a:graphicData uri="http://schemas.openxmlformats.org/drawingml/2006/table">
+            <a:tbl>
+              <a:tblPr firstRow="1" bandRow="1">
+                <a:tableStyleId>{5C22544A-7EE6-4342-B048-85BDC9FD1C3A}</a:tableStyleId>
+              </a:tblPr>
+              <a:tblGrid>
+                <a:gridCol w="2743200"/>
+                <a:gridCol w="2743200"/>
+                <a:gridCol w="2743200"/>
+              </a:tblGrid>
+              <a:tr h="0">
+                <a:tc>
+                  <a:txBody>
+                    <a:bodyPr/>
+                    <a:lstStyle/>
+                    <a:p>
+                      <a:pPr lvl="0" indent="0" marL="0">
+                        <a:buNone/>
+                      </a:pPr>
+                      <a:r>
+                        <a:rPr/>
+                        <a:t>Comparison</a:t>
+                      </a:r>
+                    </a:p>
+                  </a:txBody>
+                  <a:tcPr/>
+                </a:tc>
+                <a:tc>
+                  <a:txBody>
+                    <a:bodyPr/>
+                    <a:lstStyle/>
+                    <a:p>
+                      <a:pPr lvl="0" indent="0" marL="0">
+                        <a:buNone/>
+                      </a:pPr>
+                      <a:r>
+                        <a:rPr/>
+                        <a:t>Difference (g)</a:t>
+                      </a:r>
+                    </a:p>
+                  </a:txBody>
+                  <a:tcPr/>
+                </a:tc>
+                <a:tc>
+                  <a:txBody>
+                    <a:bodyPr/>
+                    <a:lstStyle/>
+                    <a:p>
+                      <a:pPr lvl="0" indent="0" marL="0">
+                        <a:buNone/>
+                      </a:pPr>
+                      <a:r>
+                        <a:rPr/>
+                        <a:t>95% CI (g)</a:t>
+                      </a:r>
+                    </a:p>
+                  </a:txBody>
+                  <a:tcPr/>
+                </a:tc>
+              </a:tr>
+              <a:tr h="0">
+                <a:tc>
+                  <a:txBody>
+                    <a:bodyPr/>
+                    <a:lstStyle/>
+                    <a:p>
+                      <a:pPr lvl="0" indent="0" marL="0">
+                        <a:buNone/>
+                      </a:pPr>
+                      <a:r>
+                        <a:rPr/>
+                        <a:t>Males vs females</a:t>
+                      </a:r>
+                    </a:p>
+                  </a:txBody>
+                </a:tc>
+                <a:tc>
+                  <a:txBody>
+                    <a:bodyPr/>
+                    <a:lstStyle/>
+                    <a:p>
+                      <a:pPr lvl="0" indent="0" marL="0">
+                        <a:buNone/>
+                      </a:pPr>
+                      <a:r>
+                        <a:rPr/>
+                        <a:t>668</a:t>
+                      </a:r>
+                    </a:p>
+                  </a:txBody>
+                </a:tc>
+                <a:tc>
+                  <a:txBody>
+                    <a:bodyPr/>
+                    <a:lstStyle/>
+                    <a:p>
+                      <a:pPr lvl="0" indent="0" marL="0">
+                        <a:buNone/>
+                      </a:pPr>
+                      <a:r>
+                        <a:rPr/>
+                        <a:t>599 to 736</a:t>
+                      </a:r>
+                    </a:p>
+                  </a:txBody>
+                </a:tc>
+              </a:tr>
+              <a:tr h="0">
+                <a:tc>
+                  <a:txBody>
+                    <a:bodyPr/>
+                    <a:lstStyle/>
+                    <a:p>
+                      <a:pPr lvl="0" indent="0" marL="0">
+                        <a:buNone/>
+                      </a:pPr>
+                      <a:r>
+                        <a:rPr/>
+                        <a:t>Chinstrap vs Adelie</a:t>
+                      </a:r>
+                    </a:p>
+                  </a:txBody>
+                </a:tc>
+                <a:tc>
+                  <a:txBody>
+                    <a:bodyPr/>
+                    <a:lstStyle/>
+                    <a:p>
+                      <a:pPr lvl="0" indent="0" marL="0">
+                        <a:buNone/>
+                      </a:pPr>
+                      <a:r>
+                        <a:rPr/>
+                        <a:t>27</a:t>
+                      </a:r>
+                    </a:p>
+                  </a:txBody>
+                </a:tc>
+                <a:tc>
+                  <a:txBody>
+                    <a:bodyPr/>
+                    <a:lstStyle/>
+                    <a:p>
+                      <a:pPr lvl="0" indent="0" marL="0">
+                        <a:buNone/>
+                      </a:pPr>
+                      <a:r>
+                        <a:rPr/>
+                        <a:t>−65 to 118</a:t>
+                      </a:r>
+                    </a:p>
+                  </a:txBody>
+                </a:tc>
+              </a:tr>
+              <a:tr h="0">
+                <a:tc>
+                  <a:txBody>
+                    <a:bodyPr/>
+                    <a:lstStyle/>
+                    <a:p>
+                      <a:pPr lvl="0" indent="0" marL="0">
+                        <a:buNone/>
+                      </a:pPr>
+                      <a:r>
+                        <a:rPr/>
+                        <a:t>Gentoo vs Adelie</a:t>
+                      </a:r>
+                    </a:p>
+                  </a:txBody>
+                </a:tc>
+                <a:tc>
+                  <a:txBody>
+                    <a:bodyPr/>
+                    <a:lstStyle/>
+                    <a:p>
+                      <a:pPr lvl="0" indent="0" marL="0">
+                        <a:buNone/>
+                      </a:pPr>
+                      <a:r>
+                        <a:rPr/>
+                        <a:t>1378</a:t>
+                      </a:r>
+                    </a:p>
+                  </a:txBody>
+                </a:tc>
+                <a:tc>
+                  <a:txBody>
+                    <a:bodyPr/>
+                    <a:lstStyle/>
+                    <a:p>
+                      <a:pPr lvl="0" indent="0" marL="0">
+                        <a:buNone/>
+                      </a:pPr>
+                      <a:r>
+                        <a:rPr/>
+                        <a:t>1301 to 1455</a:t>
+                      </a:r>
+                    </a:p>
+                  </a:txBody>
+                </a:tc>
+              </a:tr>
+            </a:tbl>
+          </a:graphicData>
+        </a:graphic>
+      </p:graphicFrame>
     </p:spTree>
   </p:cSld>
 </p:sld>
@@ -3988,7 +4163,7 @@
         <a:sysClr val="window" lastClr="FFFFFF"/>
       </a:lt1>
       <a:dk2>
-        <a:srgbClr val="111111"/>
+        <a:srgbClr val="1A1A1A"/>
       </a:dk2>
       <a:lt2>
         <a:srgbClr val="F5F5F5"/>
@@ -3997,22 +4172,22 @@
         <a:srgbClr val="404040"/>
       </a:accent1>
       <a:accent2>
-        <a:srgbClr val="8B0000"/>
+        <a:srgbClr val="ED1B2F"/>
       </a:accent2>
       <a:accent3>
-        <a:srgbClr val="191970"/>
+        <a:srgbClr val="1A6C7A"/>
       </a:accent3>
       <a:accent4>
         <a:srgbClr val="4477AA"/>
       </a:accent4>
       <a:accent5>
-        <a:srgbClr val="EE6677"/>
+        <a:srgbClr val="228833"/>
       </a:accent5>
       <a:accent6>
         <a:srgbClr val="997700"/>
       </a:accent6>
       <a:hlink>
-        <a:srgbClr val="8B0000"/>
+        <a:srgbClr val="177DB3"/>
       </a:hlink>
       <a:folHlink>
         <a:srgbClr val="5C5C5C"/>

</xml_diff>